<commit_message>
Add script to rescore PRIMM grades from old to new weighting system
This script converts Classroom draft grades from the old PRIMM weighting (P5 R5 I5, Modify 40, Make 25, Ext 20) to the new weighting (P10 R5 I35, Modify 30, Make 15, Ext 5). It ensures that grades never decrease and provides a method to preview changes before applying them. The script includes functionality to handle multiple courses and student submissions, and it logs all changes made.
</commit_message>
<xml_diff>
--- a/_presentations/Y9_Python/L3_While_Loops.pptx
+++ b/_presentations/Y9_Python/L3_While_Loops.pptx
@@ -126,19 +126,19 @@
   <p:extLst>
     <p:ext uri="{521415D9-36F7-43E2-AB2F-B90AF26B5E84}">
       <p14:sectionLst xmlns:p14="http://schemas.microsoft.com/office/powerpoint/2010/main">
-        <p14:section name="Recap &amp; Recall" id="{1964c26e-3c3d-3b83-c2bd-9b14e3fb323a}">
+        <p14:section name="Recap &amp; Recall" id="{09fd49c7-761b-17f7-188f-347a72a9ef38}">
           <p14:sldIdLst>
             <p14:sldId id="256"/>
             <p14:sldId id="257"/>
           </p14:sldIdLst>
         </p14:section>
-        <p14:section name="Title" id="{cbb08cf3-31dd-52ec-1540-428630e62564}">
+        <p14:section name="Title" id="{b78d03af-18f6-b465-6096-3768205745a2}">
           <p14:sldIdLst>
             <p14:sldId id="258"/>
             <p14:sldId id="259"/>
           </p14:sldIdLst>
         </p14:section>
-        <p14:section name="Iteration" id="{c2b81037-510a-1847-067b-3fdce5b8ed47}">
+        <p14:section name="Iteration" id="{fe769597-9400-2148-7a92-ef3f9f9dd743}">
           <p14:sldIdLst>
             <p14:sldId id="260"/>
             <p14:sldId id="261"/>
@@ -147,7 +147,7 @@
             <p14:sldId id="264"/>
           </p14:sldIdLst>
         </p14:section>
-        <p14:section name="Round 1 — counting" id="{7a4323d5-7f2a-8d93-bb74-2b69131f366c}">
+        <p14:section name="Round 1 — counting" id="{3ead5979-8091-eee3-aa46-108707ddb8bb}">
           <p14:sldIdLst>
             <p14:sldId id="265"/>
             <p14:sldId id="266"/>
@@ -156,24 +156,24 @@
             <p14:sldId id="269"/>
           </p14:sldIdLst>
         </p14:section>
-        <p14:section name="Round 2 — input()" id="{f201a7e5-5e45-d1eb-ab79-9f9586d50c50}">
+        <p14:section name="Round 2 — input()" id="{c0c3aa6f-bc06-1dbd-bdd5-3216f780c9cf}">
           <p14:sldIdLst>
             <p14:sldId id="270"/>
             <p14:sldId id="271"/>
           </p14:sldIdLst>
         </p14:section>
-        <p14:section name="Numbers into text" id="{3efb5a80-04de-a21f-083e-d4f0ac71a2d3}">
+        <p14:section name="Numbers into text" id="{fcc87a2c-cc0c-e155-3162-7053a7da9f07}">
           <p14:sldIdLst>
             <p14:sldId id="272"/>
           </p14:sldIdLst>
         </p14:section>
-        <p14:section name="Locked In" id="{1fca3721-6148-517d-29d8-7cdd01a9ed5e}">
+        <p14:section name="Locked In" id="{3dea5715-2065-8d76-ad8f-3c791b10f17c}">
           <p14:sldIdLst>
             <p14:sldId id="273"/>
             <p14:sldId id="274"/>
           </p14:sldIdLst>
         </p14:section>
-        <p14:section name="Plenary" id="{b617c175-2a1f-01e9-0f91-058b1aff7406}">
+        <p14:section name="Plenary" id="{da50c2aa-68bf-376d-427b-1a75208fa26f}">
           <p14:sldIdLst>
             <p14:sldId id="275"/>
           </p14:sldIdLst>
@@ -951,7 +951,7 @@
               <a:rPr lang="en-US" dirty="0"/>
               <a:t>YOU DO — silent, on your own, 4 minutes. Boards up together at the end.
 Stuck? Draw a trace table like the last two slides: one row per check.
-Number 2 is the trap: the condition is checked BEFORE the first pass. Number 3: look at the spaces in front of print.</a:t>
+Number 2 is the trap: the condition is checked BEFORE the loop runs even once. Number 3: look at the spaces in front of print.</a:t>
             </a:r>
             <a:endParaRPr lang="en-US" dirty="0"/>
           </a:p>
@@ -1041,7 +1041,7 @@
               <a:rPr lang="en-US" dirty="0"/>
               <a:t>Check boards. Most common mistakes:
 1: "1 2 3 4" — after 3 prints, n becomes 4, and 4 &lt;= 3 is False, so it stops.
-2: "5, End" — 5 &lt; 5 is False before the first pass, so the body NEVER runs. A while can run zero times.
+2: "5, End" — 5 &lt; 5 is False straight away, so the body NEVER runs. A while can run zero times.
 3: "2 4 6" — print(n) isn't indented, so it's not in the loop: it runs once, after the loop, when n is 6.
 If most of the class got 2 or 3 wrong, trace one more together before Round 2.</a:t>
             </a:r>
@@ -1131,7 +1131,7 @@
           <a:p>
             <a:r>
               <a:rPr lang="en-US" dirty="0"/>
-              <a:t>I DO — the airlock keypad, the same program as today's activity. Now the variable changes because the USER types something new each pass.
+              <a:t>I DO — the airlock keypad, the same program as today's activity. Now the variable changes because the USER types something new each time round.
 Click 1 — "Line 1 asks: 1234. Is "1234" != "4271"? Yes, True. ACCESS DENIED, then line 4 asks again: 0000."
 Click 2 — "0000 != 4271? True. ACCESS DENIED, ask again: 4271."
 Click 3 — "4271 != 4271? False. The loop ends: Airlock open."
@@ -32410,7 +32410,7 @@
                 <a:ea typeface="Calibri" pitchFamily="34" charset="-122"/>
                 <a:cs typeface="Calibri" pitchFamily="34" charset="-120"/>
               </a:rPr>
-              <a:t>Checks again before every pass</a:t>
+              <a:t>Checks again each time round</a:t>
             </a:r>
             <a:endParaRPr lang="en-US" sz="2200" dirty="0"/>
           </a:p>

</xml_diff>